<commit_message>
Refine thermal label generation
</commit_message>
<xml_diff>
--- a/features/label/thermal/src/desktopMain/resources/templates/75_120.pptx
+++ b/features/label/thermal/src/desktopMain/resources/templates/75_120.pptx
@@ -3679,25 +3679,148 @@
           <a:p>
             <a:pPr algn="l"/>
             <a:r>
-              <a:rPr sz="916" b="1">
-                <a:solidFill>
-                  <a:srgbClr val="000000"/>
-                </a:solidFill>
-                <a:latin typeface="Arial"/>
-              </a:rPr>
-              <a:t>Изготовитель:ИП Гармаш Игорь Николаевич</a:t>
-            </a:r>
+              <a:rPr sz="916" b="1" dirty="0" err="1">
+                <a:solidFill>
+                  <a:srgbClr val="000000"/>
+                </a:solidFill>
+                <a:latin typeface="Arial"/>
+              </a:rPr>
+              <a:t>Изготовитель:ИП</a:t>
+            </a:r>
+            <a:r>
+              <a:rPr sz="916" b="1" dirty="0">
+                <a:solidFill>
+                  <a:srgbClr val="000000"/>
+                </a:solidFill>
+                <a:latin typeface="Arial"/>
+              </a:rPr>
+              <a:t> </a:t>
+            </a:r>
+            <a:r>
+              <a:rPr sz="916" b="1" dirty="0" err="1">
+                <a:solidFill>
+                  <a:srgbClr val="000000"/>
+                </a:solidFill>
+                <a:latin typeface="Arial"/>
+              </a:rPr>
+              <a:t>Гармаш</a:t>
+            </a:r>
+            <a:r>
+              <a:rPr sz="916" b="1" dirty="0">
+                <a:solidFill>
+                  <a:srgbClr val="000000"/>
+                </a:solidFill>
+                <a:latin typeface="Arial"/>
+              </a:rPr>
+              <a:t> </a:t>
+            </a:r>
+            <a:r>
+              <a:rPr sz="916" b="1" dirty="0" err="1">
+                <a:solidFill>
+                  <a:srgbClr val="000000"/>
+                </a:solidFill>
+                <a:latin typeface="Arial"/>
+              </a:rPr>
+              <a:t>Игорь</a:t>
+            </a:r>
+            <a:r>
+              <a:rPr sz="916" b="1" dirty="0">
+                <a:solidFill>
+                  <a:srgbClr val="000000"/>
+                </a:solidFill>
+                <a:latin typeface="Arial"/>
+              </a:rPr>
+              <a:t> </a:t>
+            </a:r>
+            <a:r>
+              <a:rPr sz="916" b="1" dirty="0" err="1">
+                <a:solidFill>
+                  <a:srgbClr val="000000"/>
+                </a:solidFill>
+                <a:latin typeface="Arial"/>
+              </a:rPr>
+              <a:t>Николаевич</a:t>
+            </a:r>
+            <a:endParaRPr sz="916" b="1" dirty="0">
+              <a:solidFill>
+                <a:srgbClr val="000000"/>
+              </a:solidFill>
+              <a:latin typeface="Arial"/>
+            </a:endParaRPr>
           </a:p>
           <a:p>
             <a:pPr algn="l"/>
             <a:r>
-              <a:rPr sz="916" b="1">
-                <a:solidFill>
-                  <a:srgbClr val="000000"/>
-                </a:solidFill>
-                <a:latin typeface="Arial"/>
-              </a:rPr>
-              <a:t>Россия,Краснодарский край,Выселковский район,ст-ца Выселки,перПервомайский,д 19А</a:t>
+              <a:rPr sz="916" b="1" dirty="0" err="1">
+                <a:solidFill>
+                  <a:srgbClr val="000000"/>
+                </a:solidFill>
+                <a:latin typeface="Arial"/>
+              </a:rPr>
+              <a:t>Россия,Краснодарский</a:t>
+            </a:r>
+            <a:r>
+              <a:rPr sz="916" b="1" dirty="0">
+                <a:solidFill>
+                  <a:srgbClr val="000000"/>
+                </a:solidFill>
+                <a:latin typeface="Arial"/>
+              </a:rPr>
+              <a:t> </a:t>
+            </a:r>
+            <a:r>
+              <a:rPr sz="916" b="1" dirty="0" err="1">
+                <a:solidFill>
+                  <a:srgbClr val="000000"/>
+                </a:solidFill>
+                <a:latin typeface="Arial"/>
+              </a:rPr>
+              <a:t>край,Выселковский</a:t>
+            </a:r>
+            <a:r>
+              <a:rPr sz="916" b="1" dirty="0">
+                <a:solidFill>
+                  <a:srgbClr val="000000"/>
+                </a:solidFill>
+                <a:latin typeface="Arial"/>
+              </a:rPr>
+              <a:t> </a:t>
+            </a:r>
+            <a:r>
+              <a:rPr sz="916" b="1" dirty="0" err="1">
+                <a:solidFill>
+                  <a:srgbClr val="000000"/>
+                </a:solidFill>
+                <a:latin typeface="Arial"/>
+              </a:rPr>
+              <a:t>район,ст-ца</a:t>
+            </a:r>
+            <a:r>
+              <a:rPr sz="916" b="1" dirty="0">
+                <a:solidFill>
+                  <a:srgbClr val="000000"/>
+                </a:solidFill>
+                <a:latin typeface="Arial"/>
+              </a:rPr>
+              <a:t> </a:t>
+            </a:r>
+            <a:r>
+              <a:rPr sz="916" b="1" dirty="0" err="1">
+                <a:solidFill>
+                  <a:srgbClr val="000000"/>
+                </a:solidFill>
+                <a:latin typeface="Arial"/>
+              </a:rPr>
+              <a:t>Выселки,перПервомайский,д</a:t>
+            </a:r>
+            <a:r>
+              <a:rPr sz="916" b="1" dirty="0">
+                <a:solidFill>
+                  <a:srgbClr val="000000"/>
+                </a:solidFill>
+                <a:latin typeface="Arial"/>
+              </a:rPr>
+              <a:t> 19А</a:t>
             </a:r>
           </a:p>
         </p:txBody>
@@ -3710,8 +3833,8 @@
         </p:nvSpPr>
         <p:spPr>
           <a:xfrm>
-            <a:off x="40555" y="3263736"/>
-            <a:ext cx="2004870" cy="286617"/>
+            <a:off x="74997" y="3336576"/>
+            <a:ext cx="1970428" cy="140936"/>
           </a:xfrm>
           <a:prstGeom prst="rect">
             <a:avLst/>
@@ -3804,8 +3927,8 @@
         </p:nvSpPr>
         <p:spPr>
           <a:xfrm>
-            <a:off x="74997" y="3667207"/>
-            <a:ext cx="1569047" cy="139680"/>
+            <a:off x="84857" y="3667207"/>
+            <a:ext cx="1559187" cy="139680"/>
           </a:xfrm>
           <a:prstGeom prst="rect">
             <a:avLst/>

</xml_diff>